<commit_message>
Added a switch to disable the speedup that occurs when you score a point
</commit_message>
<xml_diff>
--- a/usage_guide.pptx
+++ b/usage_guide.pptx
@@ -9,7 +9,7 @@
     <p:sldId id="257" r:id="rId5"/>
   </p:sldIdLst>
   <p:sldSz cx="12192000" cy="6858000"/>
-  <p:notesSz cx="6858000" cy="9144000"/>
+  <p:notesSz cx="7010400" cy="9296400"/>
   <p:defaultTextStyle>
     <a:defPPr>
       <a:defRPr lang="en-US"/>
@@ -105,7 +105,177 @@
       </a:defRPr>
     </a:lvl9pPr>
   </p:defaultTextStyle>
+  <p:extLst>
+    <p:ext uri="{EFAFB233-063F-42B5-8137-9DF3F51BA10A}">
+      <p15:sldGuideLst xmlns:p15="http://schemas.microsoft.com/office/powerpoint/2012/main"/>
+    </p:ext>
+  </p:extLst>
 </p:presentation>
+</file>
+
+<file path=ppt/revisionInfo.xml><?xml version="1.0" encoding="utf-8"?>
+<p1510:revInfo xmlns:a="http://schemas.openxmlformats.org/drawingml/2006/main" xmlns:r="http://schemas.openxmlformats.org/officeDocument/2006/relationships" xmlns:p1510="http://schemas.microsoft.com/office/powerpoint/2015/10/main">
+  <p1510:revLst>
+    <p1510:client id="{4D0BF372-0143-4AE8-8B76-AB608A7C8084}" v="23" dt="2024-11-11T13:29:29.439"/>
+  </p1510:revLst>
+</p1510:revInfo>
+</file>
+
+<file path=ppt/changesInfos/changesInfo1.xml><?xml version="1.0" encoding="utf-8"?>
+<pc:chgInfo xmlns:a="http://schemas.openxmlformats.org/drawingml/2006/main" xmlns:r="http://schemas.openxmlformats.org/officeDocument/2006/relationships" xmlns:ac="http://schemas.microsoft.com/office/drawing/2013/main/command" xmlns:pc="http://schemas.microsoft.com/office/powerpoint/2013/main/command">
+  <pc:docChgLst>
+    <pc:chgData name="Pethick, Matthew" userId="47b0bdf2-08b5-49f1-a741-b2d87ec64f81" providerId="ADAL" clId="{4D0BF372-0143-4AE8-8B76-AB608A7C8084}"/>
+    <pc:docChg chg="undo custSel modSld">
+      <pc:chgData name="Pethick, Matthew" userId="47b0bdf2-08b5-49f1-a741-b2d87ec64f81" providerId="ADAL" clId="{4D0BF372-0143-4AE8-8B76-AB608A7C8084}" dt="2024-11-11T13:29:43.721" v="179" actId="12789"/>
+      <pc:docMkLst>
+        <pc:docMk/>
+      </pc:docMkLst>
+      <pc:sldChg chg="addSp delSp modSp mod">
+        <pc:chgData name="Pethick, Matthew" userId="47b0bdf2-08b5-49f1-a741-b2d87ec64f81" providerId="ADAL" clId="{4D0BF372-0143-4AE8-8B76-AB608A7C8084}" dt="2024-11-11T13:29:43.721" v="179" actId="12789"/>
+        <pc:sldMkLst>
+          <pc:docMk/>
+          <pc:sldMk cId="3712660401" sldId="257"/>
+        </pc:sldMkLst>
+        <pc:spChg chg="add del mod">
+          <ac:chgData name="Pethick, Matthew" userId="47b0bdf2-08b5-49f1-a741-b2d87ec64f81" providerId="ADAL" clId="{4D0BF372-0143-4AE8-8B76-AB608A7C8084}" dt="2024-11-11T13:06:06.357" v="102" actId="478"/>
+          <ac:spMkLst>
+            <pc:docMk/>
+            <pc:sldMk cId="3712660401" sldId="257"/>
+            <ac:spMk id="6" creationId="{BC1AFFD5-B2A8-CC9A-FE21-29B166D0C46D}"/>
+          </ac:spMkLst>
+        </pc:spChg>
+        <pc:spChg chg="add mod">
+          <ac:chgData name="Pethick, Matthew" userId="47b0bdf2-08b5-49f1-a741-b2d87ec64f81" providerId="ADAL" clId="{4D0BF372-0143-4AE8-8B76-AB608A7C8084}" dt="2024-11-11T13:14:56.195" v="135" actId="1035"/>
+          <ac:spMkLst>
+            <pc:docMk/>
+            <pc:sldMk cId="3712660401" sldId="257"/>
+            <ac:spMk id="7" creationId="{5A8ED71B-2C2A-05C8-E066-18E9A9AC05B9}"/>
+          </ac:spMkLst>
+        </pc:spChg>
+        <pc:spChg chg="add mod">
+          <ac:chgData name="Pethick, Matthew" userId="47b0bdf2-08b5-49f1-a741-b2d87ec64f81" providerId="ADAL" clId="{4D0BF372-0143-4AE8-8B76-AB608A7C8084}" dt="2024-11-11T13:29:29.439" v="177" actId="571"/>
+          <ac:spMkLst>
+            <pc:docMk/>
+            <pc:sldMk cId="3712660401" sldId="257"/>
+            <ac:spMk id="13" creationId="{007A81E1-BE80-8BB8-5F0F-6AC3B154DACF}"/>
+          </ac:spMkLst>
+        </pc:spChg>
+        <pc:spChg chg="mod">
+          <ac:chgData name="Pethick, Matthew" userId="47b0bdf2-08b5-49f1-a741-b2d87ec64f81" providerId="ADAL" clId="{4D0BF372-0143-4AE8-8B76-AB608A7C8084}" dt="2024-11-11T13:10:59.657" v="134" actId="20577"/>
+          <ac:spMkLst>
+            <pc:docMk/>
+            <pc:sldMk cId="3712660401" sldId="257"/>
+            <ac:spMk id="37" creationId="{E4A8F66B-7D32-4301-7B2E-222716E02861}"/>
+          </ac:spMkLst>
+        </pc:spChg>
+        <pc:spChg chg="mod ord">
+          <ac:chgData name="Pethick, Matthew" userId="47b0bdf2-08b5-49f1-a741-b2d87ec64f81" providerId="ADAL" clId="{4D0BF372-0143-4AE8-8B76-AB608A7C8084}" dt="2024-11-11T13:29:43.721" v="179" actId="12789"/>
+          <ac:spMkLst>
+            <pc:docMk/>
+            <pc:sldMk cId="3712660401" sldId="257"/>
+            <ac:spMk id="43" creationId="{62C57809-9881-2022-3565-9B7E6AF5C9B8}"/>
+          </ac:spMkLst>
+        </pc:spChg>
+        <pc:spChg chg="mod">
+          <ac:chgData name="Pethick, Matthew" userId="47b0bdf2-08b5-49f1-a741-b2d87ec64f81" providerId="ADAL" clId="{4D0BF372-0143-4AE8-8B76-AB608A7C8084}" dt="2024-11-11T13:06:20.067" v="112" actId="1038"/>
+          <ac:spMkLst>
+            <pc:docMk/>
+            <pc:sldMk cId="3712660401" sldId="257"/>
+            <ac:spMk id="56" creationId="{2C6DCEAB-90A7-F576-D7C2-5BA683AA77DC}"/>
+          </ac:spMkLst>
+        </pc:spChg>
+        <pc:grpChg chg="add mod">
+          <ac:chgData name="Pethick, Matthew" userId="47b0bdf2-08b5-49f1-a741-b2d87ec64f81" providerId="ADAL" clId="{4D0BF372-0143-4AE8-8B76-AB608A7C8084}" dt="2024-11-11T13:29:43.721" v="179" actId="12789"/>
+          <ac:grpSpMkLst>
+            <pc:docMk/>
+            <pc:sldMk cId="3712660401" sldId="257"/>
+            <ac:grpSpMk id="2" creationId="{21846AE4-D3AE-861F-A126-5904222E38C2}"/>
+          </ac:grpSpMkLst>
+        </pc:grpChg>
+        <pc:grpChg chg="mod">
+          <ac:chgData name="Pethick, Matthew" userId="47b0bdf2-08b5-49f1-a741-b2d87ec64f81" providerId="ADAL" clId="{4D0BF372-0143-4AE8-8B76-AB608A7C8084}" dt="2024-11-11T13:27:49.462" v="143" actId="164"/>
+          <ac:grpSpMkLst>
+            <pc:docMk/>
+            <pc:sldMk cId="3712660401" sldId="257"/>
+            <ac:grpSpMk id="44" creationId="{546BF22A-4081-4065-6382-5535B88F18B3}"/>
+          </ac:grpSpMkLst>
+        </pc:grpChg>
+        <pc:grpChg chg="mod">
+          <ac:chgData name="Pethick, Matthew" userId="47b0bdf2-08b5-49f1-a741-b2d87ec64f81" providerId="ADAL" clId="{4D0BF372-0143-4AE8-8B76-AB608A7C8084}" dt="2024-11-11T13:27:49.462" v="143" actId="164"/>
+          <ac:grpSpMkLst>
+            <pc:docMk/>
+            <pc:sldMk cId="3712660401" sldId="257"/>
+            <ac:grpSpMk id="47" creationId="{51E95FE4-C20B-3942-CFB0-E2EAF0C67BAF}"/>
+          </ac:grpSpMkLst>
+        </pc:grpChg>
+        <pc:grpChg chg="mod">
+          <ac:chgData name="Pethick, Matthew" userId="47b0bdf2-08b5-49f1-a741-b2d87ec64f81" providerId="ADAL" clId="{4D0BF372-0143-4AE8-8B76-AB608A7C8084}" dt="2024-11-11T13:27:49.462" v="143" actId="164"/>
+          <ac:grpSpMkLst>
+            <pc:docMk/>
+            <pc:sldMk cId="3712660401" sldId="257"/>
+            <ac:grpSpMk id="50" creationId="{B67CD042-4161-6A57-4273-D5825E61A143}"/>
+          </ac:grpSpMkLst>
+        </pc:grpChg>
+        <pc:grpChg chg="mod">
+          <ac:chgData name="Pethick, Matthew" userId="47b0bdf2-08b5-49f1-a741-b2d87ec64f81" providerId="ADAL" clId="{4D0BF372-0143-4AE8-8B76-AB608A7C8084}" dt="2024-11-11T13:27:49.462" v="143" actId="164"/>
+          <ac:grpSpMkLst>
+            <pc:docMk/>
+            <pc:sldMk cId="3712660401" sldId="257"/>
+            <ac:grpSpMk id="53" creationId="{9BE2784E-2B14-97F2-C676-6AA58F7B9EAB}"/>
+          </ac:grpSpMkLst>
+        </pc:grpChg>
+        <pc:picChg chg="mod">
+          <ac:chgData name="Pethick, Matthew" userId="47b0bdf2-08b5-49f1-a741-b2d87ec64f81" providerId="ADAL" clId="{4D0BF372-0143-4AE8-8B76-AB608A7C8084}" dt="2024-11-11T13:28:29.286" v="167" actId="1037"/>
+          <ac:picMkLst>
+            <pc:docMk/>
+            <pc:sldMk cId="3712660401" sldId="257"/>
+            <ac:picMk id="32" creationId="{1C567C94-DF8C-B444-7B7C-E8C4FCC25C8B}"/>
+          </ac:picMkLst>
+        </pc:picChg>
+        <pc:cxnChg chg="add mod">
+          <ac:chgData name="Pethick, Matthew" userId="47b0bdf2-08b5-49f1-a741-b2d87ec64f81" providerId="ADAL" clId="{4D0BF372-0143-4AE8-8B76-AB608A7C8084}" dt="2024-11-11T13:15:56.485" v="137" actId="208"/>
+          <ac:cxnSpMkLst>
+            <pc:docMk/>
+            <pc:sldMk cId="3712660401" sldId="257"/>
+            <ac:cxnSpMk id="8" creationId="{207D279B-ACFD-FB8A-02B4-C5E220D621D3}"/>
+          </ac:cxnSpMkLst>
+        </pc:cxnChg>
+        <pc:cxnChg chg="mod">
+          <ac:chgData name="Pethick, Matthew" userId="47b0bdf2-08b5-49f1-a741-b2d87ec64f81" providerId="ADAL" clId="{4D0BF372-0143-4AE8-8B76-AB608A7C8084}" dt="2024-11-11T13:28:42.882" v="168" actId="14100"/>
+          <ac:cxnSpMkLst>
+            <pc:docMk/>
+            <pc:sldMk cId="3712660401" sldId="257"/>
+            <ac:cxnSpMk id="35" creationId="{03399DFA-1B81-D2AB-DCCB-91B413D68FDD}"/>
+          </ac:cxnSpMkLst>
+        </pc:cxnChg>
+        <pc:cxnChg chg="mod">
+          <ac:chgData name="Pethick, Matthew" userId="47b0bdf2-08b5-49f1-a741-b2d87ec64f81" providerId="ADAL" clId="{4D0BF372-0143-4AE8-8B76-AB608A7C8084}" dt="2024-11-11T13:07:23.673" v="128" actId="14100"/>
+          <ac:cxnSpMkLst>
+            <pc:docMk/>
+            <pc:sldMk cId="3712660401" sldId="257"/>
+            <ac:cxnSpMk id="39" creationId="{7A271D3B-60A6-AE68-DD18-916178C23E31}"/>
+          </ac:cxnSpMkLst>
+        </pc:cxnChg>
+        <pc:cxnChg chg="mod">
+          <ac:chgData name="Pethick, Matthew" userId="47b0bdf2-08b5-49f1-a741-b2d87ec64f81" providerId="ADAL" clId="{4D0BF372-0143-4AE8-8B76-AB608A7C8084}" dt="2024-11-11T13:28:50.358" v="169" actId="14100"/>
+          <ac:cxnSpMkLst>
+            <pc:docMk/>
+            <pc:sldMk cId="3712660401" sldId="257"/>
+            <ac:cxnSpMk id="42" creationId="{3242EC64-5BB9-EF3E-A8A6-495DBA59D873}"/>
+          </ac:cxnSpMkLst>
+        </pc:cxnChg>
+        <pc:cxnChg chg="mod">
+          <ac:chgData name="Pethick, Matthew" userId="47b0bdf2-08b5-49f1-a741-b2d87ec64f81" providerId="ADAL" clId="{4D0BF372-0143-4AE8-8B76-AB608A7C8084}" dt="2024-11-11T13:29:43.721" v="179" actId="12789"/>
+          <ac:cxnSpMkLst>
+            <pc:docMk/>
+            <pc:sldMk cId="3712660401" sldId="257"/>
+            <ac:cxnSpMk id="58" creationId="{108DB30E-207D-964A-5CCE-64B4479EB74C}"/>
+          </ac:cxnSpMkLst>
+        </pc:cxnChg>
+      </pc:sldChg>
+    </pc:docChg>
+  </pc:docChgLst>
+</pc:chgInfo>
 </file>
 
 <file path=ppt/slideLayouts/slideLayout1.xml><?xml version="1.0" encoding="utf-8"?>
@@ -920,7 +1090,7 @@
         <p:fade/>
       </p:transition>
     </mc:Choice>
-    <mc:Fallback xmlns:p15="http://schemas.microsoft.com/office/powerpoint/2012/main" xmlns:a14="http://schemas.microsoft.com/office/drawing/2010/main" xmlns:a16="http://schemas.microsoft.com/office/drawing/2014/main" xmlns="">
+    <mc:Fallback xmlns="" xmlns:a16="http://schemas.microsoft.com/office/drawing/2014/main" xmlns:a14="http://schemas.microsoft.com/office/drawing/2010/main" xmlns:p15="http://schemas.microsoft.com/office/powerpoint/2012/main">
       <p:transition spd="med">
         <p:fade/>
       </p:transition>
@@ -1170,7 +1340,7 @@
         <p:fade/>
       </p:transition>
     </mc:Choice>
-    <mc:Fallback xmlns:a16="http://schemas.microsoft.com/office/drawing/2014/main" xmlns:a14="http://schemas.microsoft.com/office/drawing/2010/main" xmlns:p15="http://schemas.microsoft.com/office/powerpoint/2012/main" xmlns="">
+    <mc:Fallback xmlns="" xmlns:p15="http://schemas.microsoft.com/office/powerpoint/2012/main" xmlns:a14="http://schemas.microsoft.com/office/drawing/2010/main" xmlns:a16="http://schemas.microsoft.com/office/drawing/2014/main">
       <p:transition spd="med">
         <p:fade/>
       </p:transition>
@@ -15231,7 +15401,7 @@
         <p:fade/>
       </p:transition>
     </mc:Choice>
-    <mc:Fallback xmlns:p15="http://schemas.microsoft.com/office/powerpoint/2012/main" xmlns:a14="http://schemas.microsoft.com/office/drawing/2010/main" xmlns:a16="http://schemas.microsoft.com/office/drawing/2014/main" xmlns="">
+    <mc:Fallback xmlns="" xmlns:a16="http://schemas.microsoft.com/office/drawing/2014/main" xmlns:a14="http://schemas.microsoft.com/office/drawing/2010/main" xmlns:p15="http://schemas.microsoft.com/office/powerpoint/2012/main">
       <p:transition spd="med">
         <p:fade/>
       </p:transition>
@@ -20837,7 +21007,7 @@
         </p:blipFill>
         <p:spPr bwMode="auto">
           <a:xfrm>
-            <a:off x="6466599" y="765978"/>
+            <a:off x="6472065" y="771787"/>
             <a:ext cx="4762500" cy="3571875"/>
           </a:xfrm>
           <a:prstGeom prst="rect">
@@ -20940,7 +21110,7 @@
         <p:spPr>
           <a:xfrm flipH="1" flipV="1">
             <a:off x="10665261" y="3899591"/>
-            <a:ext cx="261686" cy="2079249"/>
+            <a:ext cx="261686" cy="2044869"/>
           </a:xfrm>
           <a:prstGeom prst="line">
             <a:avLst/>
@@ -20959,6 +21129,90 @@
       </p:cxnSp>
       <p:sp>
         <p:nvSpPr>
+          <p:cNvPr id="43" name="Rectangle 42">
+            <a:extLst>
+              <a:ext uri="{FF2B5EF4-FFF2-40B4-BE49-F238E27FC236}">
+                <a16:creationId xmlns:a16="http://schemas.microsoft.com/office/drawing/2014/main" id="{62C57809-9881-2022-3565-9B7E6AF5C9B8}"/>
+              </a:ext>
+            </a:extLst>
+          </p:cNvPr>
+          <p:cNvSpPr/>
+          <p:nvPr/>
+        </p:nvSpPr>
+        <p:spPr bwMode="auto">
+          <a:xfrm>
+            <a:off x="6436519" y="4790998"/>
+            <a:ext cx="4490428" cy="1153462"/>
+          </a:xfrm>
+          <a:prstGeom prst="rect">
+            <a:avLst/>
+          </a:prstGeom>
+          <a:solidFill>
+            <a:srgbClr val="FFFFFF"/>
+          </a:solidFill>
+          <a:ln w="38100" cap="flat" cmpd="sng" algn="ctr">
+            <a:solidFill>
+              <a:srgbClr val="ED1C24"/>
+            </a:solidFill>
+            <a:prstDash val="solid"/>
+            <a:headEnd type="none" w="med" len="med"/>
+            <a:tailEnd type="none" w="med" len="med"/>
+          </a:ln>
+          <a:effectLst/>
+        </p:spPr>
+        <p:txBody>
+          <a:bodyPr rot="0" spcFirstLastPara="0" vertOverflow="overflow" horzOverflow="overflow" vert="horz" wrap="square" lIns="182880" tIns="146304" rIns="182880" bIns="146304" numCol="1" spcCol="0" rtlCol="0" fromWordArt="0" anchor="t" anchorCtr="0" forceAA="0" compatLnSpc="1">
+            <a:prstTxWarp prst="textNoShape">
+              <a:avLst/>
+            </a:prstTxWarp>
+            <a:noAutofit/>
+          </a:bodyPr>
+          <a:lstStyle/>
+          <a:p>
+            <a:pPr marL="0" marR="0" lvl="0" indent="0" defTabSz="932472" eaLnBrk="1" fontAlgn="base" latinLnBrk="0" hangingPunct="1">
+              <a:lnSpc>
+                <a:spcPct val="100000"/>
+              </a:lnSpc>
+              <a:spcBef>
+                <a:spcPct val="0"/>
+              </a:spcBef>
+              <a:spcAft>
+                <a:spcPct val="0"/>
+              </a:spcAft>
+              <a:buClrTx/>
+              <a:buSzTx/>
+              <a:buFontTx/>
+              <a:buNone/>
+              <a:tabLst/>
+              <a:defRPr/>
+            </a:pPr>
+            <a:endParaRPr kumimoji="0" lang="en-GB" sz="1800" b="0" i="0" u="none" strike="noStrike" kern="0" cap="none" spc="0" normalizeH="0" baseline="0" noProof="0" dirty="0" err="1">
+              <a:ln>
+                <a:noFill/>
+              </a:ln>
+              <a:gradFill>
+                <a:gsLst>
+                  <a:gs pos="0">
+                    <a:srgbClr val="FFFFFF"/>
+                  </a:gs>
+                  <a:gs pos="100000">
+                    <a:srgbClr val="FFFFFF"/>
+                  </a:gs>
+                </a:gsLst>
+                <a:lin ang="5400000" scaled="0"/>
+              </a:gradFill>
+              <a:effectLst/>
+              <a:uLnTx/>
+              <a:uFillTx/>
+              <a:latin typeface="Klavika Regular"/>
+              <a:ea typeface="Segoe UI" pitchFamily="34" charset="0"/>
+              <a:cs typeface="Segoe UI" pitchFamily="34" charset="0"/>
+            </a:endParaRPr>
+          </a:p>
+        </p:txBody>
+      </p:sp>
+      <p:sp>
+        <p:nvSpPr>
           <p:cNvPr id="36" name="Title 1">
             <a:extLst>
               <a:ext uri="{FF2B5EF4-FFF2-40B4-BE49-F238E27FC236}">
@@ -21026,7 +21280,7 @@
               <a:defRPr/>
             </a:pPr>
             <a:r>
-              <a:rPr kumimoji="0" lang="en-GB" sz="4800" b="1" i="0" u="none" strike="noStrike" kern="1200" cap="none" spc="0" normalizeH="0" baseline="0" noProof="0">
+              <a:rPr kumimoji="0" lang="en-GB" sz="4800" b="1" i="0" u="none" strike="noStrike" kern="1200" cap="none" spc="0" normalizeH="0" baseline="0" noProof="0" dirty="0" err="1">
                 <a:ln w="3175">
                   <a:noFill/>
                 </a:ln>
@@ -21040,22 +21294,25 @@
                 <a:ea typeface="+mn-ea"/>
                 <a:cs typeface="Segoe UI" pitchFamily="34" charset="0"/>
               </a:rPr>
-              <a:t>snake_game on FPGA</a:t>
-            </a:r>
-            <a:endParaRPr kumimoji="0" lang="en-GB" sz="4800" b="1" i="0" u="none" strike="noStrike" kern="1200" cap="none" spc="0" normalizeH="0" baseline="0" noProof="0" dirty="0">
-              <a:ln w="3175">
-                <a:noFill/>
-              </a:ln>
-              <a:solidFill>
-                <a:srgbClr val="000000"/>
-              </a:solidFill>
-              <a:effectLst/>
-              <a:uLnTx/>
-              <a:uFillTx/>
-              <a:latin typeface="Klavika Light"/>
-              <a:ea typeface="+mn-ea"/>
-              <a:cs typeface="Segoe UI" pitchFamily="34" charset="0"/>
-            </a:endParaRPr>
+              <a:t>snake_game</a:t>
+            </a:r>
+            <a:r>
+              <a:rPr kumimoji="0" lang="en-GB" sz="4800" b="1" i="0" u="none" strike="noStrike" kern="1200" cap="none" spc="0" normalizeH="0" baseline="0" noProof="0" dirty="0">
+                <a:ln w="3175">
+                  <a:noFill/>
+                </a:ln>
+                <a:solidFill>
+                  <a:srgbClr val="000000"/>
+                </a:solidFill>
+                <a:effectLst/>
+                <a:uLnTx/>
+                <a:uFillTx/>
+                <a:latin typeface="Klavika Light"/>
+                <a:ea typeface="+mn-ea"/>
+                <a:cs typeface="Segoe UI" pitchFamily="34" charset="0"/>
+              </a:rPr>
+              <a:t> on FPGA</a:t>
+            </a:r>
           </a:p>
         </p:txBody>
       </p:sp>
@@ -21299,7 +21556,7 @@
               <a:defRPr/>
             </a:pPr>
             <a:r>
-              <a:rPr kumimoji="0" lang="en-US" sz="2400" b="0" i="0" u="none" strike="noStrike" kern="1200" cap="none" spc="0" normalizeH="0" baseline="0" noProof="0">
+              <a:rPr kumimoji="0" lang="en-US" sz="2400" b="0" i="0" u="none" strike="noStrike" kern="1200" cap="none" spc="0" normalizeH="0" baseline="0" noProof="0" dirty="0">
                 <a:ln>
                   <a:noFill/>
                 </a:ln>
@@ -21337,7 +21594,7 @@
               <a:defRPr/>
             </a:pPr>
             <a:r>
-              <a:rPr kumimoji="0" lang="en-US" sz="2400" b="0" i="0" u="none" strike="noStrike" kern="1200" cap="none" spc="0" normalizeH="0" baseline="0" noProof="0">
+              <a:rPr kumimoji="0" lang="en-US" sz="2400" b="0" i="0" u="none" strike="noStrike" kern="1200" cap="none" spc="0" normalizeH="0" baseline="0" noProof="0" dirty="0">
                 <a:ln>
                   <a:noFill/>
                 </a:ln>
@@ -21352,6 +21609,31 @@
                 <a:cs typeface="Segoe UI" panose="020B0502040204020203" pitchFamily="34" charset="0"/>
               </a:rPr>
               <a:t>Get to 10 points to win! </a:t>
+            </a:r>
+          </a:p>
+          <a:p>
+            <a:pPr>
+              <a:buClr>
+                <a:srgbClr val="636466"/>
+              </a:buClr>
+              <a:defRPr/>
+            </a:pPr>
+            <a:r>
+              <a:rPr kumimoji="0" lang="en-US" sz="2400" b="0" i="0" u="none" strike="noStrike" kern="1200" cap="none" spc="0" normalizeH="0" baseline="0" noProof="0" dirty="0">
+                <a:ln>
+                  <a:noFill/>
+                </a:ln>
+                <a:solidFill>
+                  <a:srgbClr val="000000"/>
+                </a:solidFill>
+                <a:effectLst/>
+                <a:uLnTx/>
+                <a:uFillTx/>
+                <a:latin typeface="Klavika Regular"/>
+                <a:ea typeface="+mn-ea"/>
+                <a:cs typeface="Segoe UI" panose="020B0502040204020203" pitchFamily="34" charset="0"/>
+              </a:rPr>
+              <a:t>Every time you score a point the snake becomes faster. This increase can be turned off using this switch.</a:t>
             </a:r>
           </a:p>
           <a:p>
@@ -21375,7 +21657,7 @@
               <a:defRPr/>
             </a:pPr>
             <a:r>
-              <a:rPr kumimoji="0" lang="en-US" sz="2400" b="0" i="0" u="none" strike="noStrike" kern="1200" cap="none" spc="0" normalizeH="0" baseline="0" noProof="0">
+              <a:rPr kumimoji="0" lang="en-US" sz="2400" b="0" i="0" u="none" strike="noStrike" kern="1200" cap="none" spc="0" normalizeH="0" baseline="0" noProof="0" dirty="0">
                 <a:ln>
                   <a:noFill/>
                 </a:ln>
@@ -21413,7 +21695,7 @@
               <a:defRPr/>
             </a:pPr>
             <a:r>
-              <a:rPr kumimoji="0" lang="en-US" sz="2400" b="0" i="0" u="none" strike="noStrike" kern="1200" cap="none" spc="0" normalizeH="0" baseline="0" noProof="0">
+              <a:rPr kumimoji="0" lang="en-US" sz="2400" b="0" i="0" u="none" strike="noStrike" kern="1200" cap="none" spc="0" normalizeH="0" baseline="0" noProof="0" dirty="0">
                 <a:ln>
                   <a:noFill/>
                 </a:ln>
@@ -21427,7 +21709,7 @@
                 <a:ea typeface="+mn-ea"/>
                 <a:cs typeface="Segoe UI" panose="020B0502040204020203" pitchFamily="34" charset="0"/>
               </a:rPr>
-              <a:t>Every time you score a point the snake becomes faster</a:t>
+              <a:t>You lose if you touch an edge or eat part of yourself</a:t>
             </a:r>
           </a:p>
           <a:p>
@@ -21451,7 +21733,7 @@
               <a:defRPr/>
             </a:pPr>
             <a:r>
-              <a:rPr kumimoji="0" lang="en-US" sz="2400" b="0" i="0" u="none" strike="noStrike" kern="1200" cap="none" spc="0" normalizeH="0" baseline="0" noProof="0">
+              <a:rPr kumimoji="0" lang="en-US" sz="2400" b="0" i="0" u="none" strike="noStrike" kern="1200" cap="none" spc="0" normalizeH="0" baseline="0" noProof="0" dirty="0">
                 <a:ln>
                   <a:noFill/>
                 </a:ln>
@@ -21465,7 +21747,7 @@
                 <a:ea typeface="+mn-ea"/>
                 <a:cs typeface="Segoe UI" panose="020B0502040204020203" pitchFamily="34" charset="0"/>
               </a:rPr>
-              <a:t>You lose if you touch an edge or eat part of yourself</a:t>
+              <a:t>Use the reset switch to start over in the event of a win or lose screen</a:t>
             </a:r>
           </a:p>
           <a:p>
@@ -21489,45 +21771,7 @@
               <a:defRPr/>
             </a:pPr>
             <a:r>
-              <a:rPr kumimoji="0" lang="en-US" sz="2400" b="0" i="0" u="none" strike="noStrike" kern="1200" cap="none" spc="0" normalizeH="0" baseline="0" noProof="0">
-                <a:ln>
-                  <a:noFill/>
-                </a:ln>
-                <a:solidFill>
-                  <a:srgbClr val="000000"/>
-                </a:solidFill>
-                <a:effectLst/>
-                <a:uLnTx/>
-                <a:uFillTx/>
-                <a:latin typeface="Klavika Regular"/>
-                <a:ea typeface="+mn-ea"/>
-                <a:cs typeface="Segoe UI" panose="020B0502040204020203" pitchFamily="34" charset="0"/>
-              </a:rPr>
-              <a:t>Use the reset switch to start over in the event of a win or lose screen</a:t>
-            </a:r>
-          </a:p>
-          <a:p>
-            <a:pPr marL="228600" marR="0" lvl="0" indent="-228600" algn="l" defTabSz="932742" rtl="0" eaLnBrk="1" fontAlgn="auto" latinLnBrk="0" hangingPunct="1">
-              <a:lnSpc>
-                <a:spcPct val="100000"/>
-              </a:lnSpc>
-              <a:spcBef>
-                <a:spcPts val="600"/>
-              </a:spcBef>
-              <a:spcAft>
-                <a:spcPts val="0"/>
-              </a:spcAft>
-              <a:buClr>
-                <a:srgbClr val="636466"/>
-              </a:buClr>
-              <a:buSzPct val="90000"/>
-              <a:buFont typeface="Arial" panose="020B0604020202020204" pitchFamily="34" charset="0"/>
-              <a:buChar char="•"/>
-              <a:tabLst/>
-              <a:defRPr/>
-            </a:pPr>
-            <a:r>
-              <a:rPr kumimoji="0" lang="en-US" sz="2400" b="0" i="0" u="none" strike="noStrike" kern="1200" cap="none" spc="0" normalizeH="0" baseline="0" noProof="0">
+              <a:rPr kumimoji="0" lang="en-US" sz="2400" b="0" i="0" u="none" strike="noStrike" kern="1200" cap="none" spc="0" normalizeH="0" baseline="0" noProof="0" dirty="0">
                 <a:ln>
                   <a:noFill/>
                 </a:ln>
@@ -21543,20 +21787,6 @@
               </a:rPr>
               <a:t>The directions the press buttons control are shown to the right</a:t>
             </a:r>
-            <a:endParaRPr kumimoji="0" lang="en-US" sz="2400" b="0" i="0" u="none" strike="noStrike" kern="1200" cap="none" spc="0" normalizeH="0" baseline="0" noProof="0" dirty="0">
-              <a:ln>
-                <a:noFill/>
-              </a:ln>
-              <a:solidFill>
-                <a:srgbClr val="000000"/>
-              </a:solidFill>
-              <a:effectLst/>
-              <a:uLnTx/>
-              <a:uFillTx/>
-              <a:latin typeface="Klavika Regular"/>
-              <a:ea typeface="+mn-ea"/>
-              <a:cs typeface="Segoe UI" panose="020B0502040204020203" pitchFamily="34" charset="0"/>
-            </a:endParaRPr>
           </a:p>
         </p:txBody>
       </p:sp>
@@ -21659,8 +21889,8 @@
         </p:nvCxnSpPr>
         <p:spPr>
           <a:xfrm>
-            <a:off x="4886666" y="2490537"/>
-            <a:ext cx="2418669" cy="1308554"/>
+            <a:off x="5005598" y="3667372"/>
+            <a:ext cx="2299737" cy="131719"/>
           </a:xfrm>
           <a:prstGeom prst="straightConnector1">
             <a:avLst/>
@@ -21811,8 +22041,8 @@
         </p:nvCxnSpPr>
         <p:spPr>
           <a:xfrm flipV="1">
-            <a:off x="4886666" y="3916746"/>
-            <a:ext cx="4387023" cy="1022217"/>
+            <a:off x="5397500" y="3916746"/>
+            <a:ext cx="3907939" cy="994136"/>
           </a:xfrm>
           <a:prstGeom prst="straightConnector1">
             <a:avLst/>
@@ -21829,96 +22059,12 @@
           <a:effectLst/>
         </p:spPr>
       </p:cxnSp>
-      <p:sp>
-        <p:nvSpPr>
-          <p:cNvPr id="43" name="Rectangle 42">
-            <a:extLst>
-              <a:ext uri="{FF2B5EF4-FFF2-40B4-BE49-F238E27FC236}">
-                <a16:creationId xmlns:a16="http://schemas.microsoft.com/office/drawing/2014/main" id="{62C57809-9881-2022-3565-9B7E6AF5C9B8}"/>
-              </a:ext>
-            </a:extLst>
-          </p:cNvPr>
-          <p:cNvSpPr/>
-          <p:nvPr/>
-        </p:nvSpPr>
-        <p:spPr bwMode="auto">
-          <a:xfrm>
-            <a:off x="6436519" y="4775409"/>
-            <a:ext cx="4500186" cy="1203431"/>
-          </a:xfrm>
-          <a:prstGeom prst="rect">
-            <a:avLst/>
-          </a:prstGeom>
-          <a:solidFill>
-            <a:srgbClr val="FFFFFF"/>
-          </a:solidFill>
-          <a:ln w="38100" cap="flat" cmpd="sng" algn="ctr">
-            <a:solidFill>
-              <a:srgbClr val="ED1C24"/>
-            </a:solidFill>
-            <a:prstDash val="solid"/>
-            <a:headEnd type="none" w="med" len="med"/>
-            <a:tailEnd type="none" w="med" len="med"/>
-          </a:ln>
-          <a:effectLst/>
-        </p:spPr>
-        <p:txBody>
-          <a:bodyPr rot="0" spcFirstLastPara="0" vertOverflow="overflow" horzOverflow="overflow" vert="horz" wrap="square" lIns="182880" tIns="146304" rIns="182880" bIns="146304" numCol="1" spcCol="0" rtlCol="0" fromWordArt="0" anchor="t" anchorCtr="0" forceAA="0" compatLnSpc="1">
-            <a:prstTxWarp prst="textNoShape">
-              <a:avLst/>
-            </a:prstTxWarp>
-            <a:noAutofit/>
-          </a:bodyPr>
-          <a:lstStyle/>
-          <a:p>
-            <a:pPr marL="0" marR="0" lvl="0" indent="0" defTabSz="932472" eaLnBrk="1" fontAlgn="base" latinLnBrk="0" hangingPunct="1">
-              <a:lnSpc>
-                <a:spcPct val="100000"/>
-              </a:lnSpc>
-              <a:spcBef>
-                <a:spcPct val="0"/>
-              </a:spcBef>
-              <a:spcAft>
-                <a:spcPct val="0"/>
-              </a:spcAft>
-              <a:buClrTx/>
-              <a:buSzTx/>
-              <a:buFontTx/>
-              <a:buNone/>
-              <a:tabLst/>
-              <a:defRPr/>
-            </a:pPr>
-            <a:endParaRPr kumimoji="0" lang="en-GB" sz="1800" b="0" i="0" u="none" strike="noStrike" kern="0" cap="none" spc="0" normalizeH="0" baseline="0" noProof="0" dirty="0" err="1">
-              <a:ln>
-                <a:noFill/>
-              </a:ln>
-              <a:gradFill>
-                <a:gsLst>
-                  <a:gs pos="0">
-                    <a:srgbClr val="FFFFFF"/>
-                  </a:gs>
-                  <a:gs pos="100000">
-                    <a:srgbClr val="FFFFFF"/>
-                  </a:gs>
-                </a:gsLst>
-                <a:lin ang="5400000" scaled="0"/>
-              </a:gradFill>
-              <a:effectLst/>
-              <a:uLnTx/>
-              <a:uFillTx/>
-              <a:latin typeface="Klavika Regular"/>
-              <a:ea typeface="Segoe UI" pitchFamily="34" charset="0"/>
-              <a:cs typeface="Segoe UI" pitchFamily="34" charset="0"/>
-            </a:endParaRPr>
-          </a:p>
-        </p:txBody>
-      </p:sp>
       <p:grpSp>
         <p:nvGrpSpPr>
-          <p:cNvPr id="44" name="Group 43">
-            <a:extLst>
-              <a:ext uri="{FF2B5EF4-FFF2-40B4-BE49-F238E27FC236}">
-                <a16:creationId xmlns:a16="http://schemas.microsoft.com/office/drawing/2014/main" id="{546BF22A-4081-4065-6382-5535B88F18B3}"/>
+          <p:cNvPr id="2" name="Group 1">
+            <a:extLst>
+              <a:ext uri="{FF2B5EF4-FFF2-40B4-BE49-F238E27FC236}">
+                <a16:creationId xmlns:a16="http://schemas.microsoft.com/office/drawing/2014/main" id="{21846AE4-D3AE-861F-A126-5904222E38C2}"/>
               </a:ext>
             </a:extLst>
           </p:cNvPr>
@@ -21927,547 +22073,568 @@
         </p:nvGrpSpPr>
         <p:grpSpPr>
           <a:xfrm>
-            <a:off x="8769159" y="4892484"/>
-            <a:ext cx="914401" cy="914401"/>
-            <a:chOff x="6777933" y="4956926"/>
-            <a:chExt cx="914401" cy="914401"/>
+            <a:off x="6585302" y="4899884"/>
+            <a:ext cx="4192862" cy="935690"/>
+            <a:chOff x="6617512" y="4892483"/>
+            <a:chExt cx="4192862" cy="935690"/>
           </a:xfrm>
         </p:grpSpPr>
-        <p:pic>
-          <p:nvPicPr>
-            <p:cNvPr id="45" name="Graphic 44" descr="Chevron arrows with solid fill">
+        <p:grpSp>
+          <p:nvGrpSpPr>
+            <p:cNvPr id="44" name="Group 43">
               <a:extLst>
                 <a:ext uri="{FF2B5EF4-FFF2-40B4-BE49-F238E27FC236}">
-                  <a16:creationId xmlns:a16="http://schemas.microsoft.com/office/drawing/2014/main" id="{344C4812-2A2B-ED0A-AC3B-C872CD74A474}"/>
+                  <a16:creationId xmlns:a16="http://schemas.microsoft.com/office/drawing/2014/main" id="{546BF22A-4081-4065-6382-5535B88F18B3}"/>
                 </a:ext>
               </a:extLst>
             </p:cNvPr>
-            <p:cNvPicPr>
-              <a:picLocks noChangeAspect="1"/>
-            </p:cNvPicPr>
+            <p:cNvGrpSpPr/>
             <p:nvPr/>
-          </p:nvPicPr>
-          <p:blipFill>
-            <a:blip r:embed="rId3">
-              <a:extLst>
-                <a:ext uri="{96DAC541-7B7A-43D3-8B79-37D633B846F1}">
-                  <asvg:svgBlip xmlns:asvg="http://schemas.microsoft.com/office/drawing/2016/SVG/main" r:embed="rId4"/>
-                </a:ext>
-              </a:extLst>
-            </a:blip>
-            <a:stretch>
-              <a:fillRect/>
-            </a:stretch>
-          </p:blipFill>
-          <p:spPr>
-            <a:xfrm rot="10800000">
-              <a:off x="6777934" y="4956926"/>
-              <a:ext cx="914400" cy="914400"/>
+          </p:nvGrpSpPr>
+          <p:grpSpPr>
+            <a:xfrm>
+              <a:off x="8769159" y="4892484"/>
+              <a:ext cx="914401" cy="914401"/>
+              <a:chOff x="6777933" y="4956926"/>
+              <a:chExt cx="914401" cy="914401"/>
             </a:xfrm>
-            <a:prstGeom prst="rect">
-              <a:avLst/>
-            </a:prstGeom>
-          </p:spPr>
-        </p:pic>
-        <p:sp>
-          <p:nvSpPr>
-            <p:cNvPr id="46" name="Rectangle 45">
+          </p:grpSpPr>
+          <p:pic>
+            <p:nvPicPr>
+              <p:cNvPr id="45" name="Graphic 44" descr="Chevron arrows with solid fill">
+                <a:extLst>
+                  <a:ext uri="{FF2B5EF4-FFF2-40B4-BE49-F238E27FC236}">
+                    <a16:creationId xmlns:a16="http://schemas.microsoft.com/office/drawing/2014/main" id="{344C4812-2A2B-ED0A-AC3B-C872CD74A474}"/>
+                  </a:ext>
+                </a:extLst>
+              </p:cNvPr>
+              <p:cNvPicPr>
+                <a:picLocks noChangeAspect="1"/>
+              </p:cNvPicPr>
+              <p:nvPr/>
+            </p:nvPicPr>
+            <p:blipFill>
+              <a:blip r:embed="rId3">
+                <a:extLst>
+                  <a:ext uri="{96DAC541-7B7A-43D3-8B79-37D633B846F1}">
+                    <asvg:svgBlip xmlns:asvg="http://schemas.microsoft.com/office/drawing/2016/SVG/main" r:embed="rId4"/>
+                  </a:ext>
+                </a:extLst>
+              </a:blip>
+              <a:stretch>
+                <a:fillRect/>
+              </a:stretch>
+            </p:blipFill>
+            <p:spPr>
+              <a:xfrm rot="10800000">
+                <a:off x="6777934" y="4956926"/>
+                <a:ext cx="914400" cy="914400"/>
+              </a:xfrm>
+              <a:prstGeom prst="rect">
+                <a:avLst/>
+              </a:prstGeom>
+            </p:spPr>
+          </p:pic>
+          <p:sp>
+            <p:nvSpPr>
+              <p:cNvPr id="46" name="Rectangle 45">
+                <a:extLst>
+                  <a:ext uri="{FF2B5EF4-FFF2-40B4-BE49-F238E27FC236}">
+                    <a16:creationId xmlns:a16="http://schemas.microsoft.com/office/drawing/2014/main" id="{3F561B45-DDC4-EBAA-A5CF-8FC6140B0D80}"/>
+                  </a:ext>
+                </a:extLst>
+              </p:cNvPr>
+              <p:cNvSpPr/>
+              <p:nvPr/>
+            </p:nvSpPr>
+            <p:spPr bwMode="auto">
+              <a:xfrm>
+                <a:off x="6777933" y="4956926"/>
+                <a:ext cx="914401" cy="914401"/>
+              </a:xfrm>
+              <a:prstGeom prst="rect">
+                <a:avLst/>
+              </a:prstGeom>
+              <a:noFill/>
+              <a:ln w="38100" cap="flat" cmpd="sng" algn="ctr">
+                <a:solidFill>
+                  <a:srgbClr val="000000"/>
+                </a:solidFill>
+                <a:prstDash val="solid"/>
+                <a:headEnd type="none" w="med" len="med"/>
+                <a:tailEnd type="none" w="med" len="med"/>
+              </a:ln>
+              <a:effectLst/>
+            </p:spPr>
+            <p:txBody>
+              <a:bodyPr rot="0" spcFirstLastPara="0" vertOverflow="overflow" horzOverflow="overflow" vert="horz" wrap="square" lIns="182880" tIns="146304" rIns="182880" bIns="146304" numCol="1" spcCol="0" rtlCol="0" fromWordArt="0" anchor="t" anchorCtr="0" forceAA="0" compatLnSpc="1">
+                <a:prstTxWarp prst="textNoShape">
+                  <a:avLst/>
+                </a:prstTxWarp>
+                <a:noAutofit/>
+              </a:bodyPr>
+              <a:lstStyle/>
+              <a:p>
+                <a:pPr marL="0" marR="0" lvl="0" indent="0" defTabSz="932472" eaLnBrk="1" fontAlgn="base" latinLnBrk="0" hangingPunct="1">
+                  <a:lnSpc>
+                    <a:spcPct val="100000"/>
+                  </a:lnSpc>
+                  <a:spcBef>
+                    <a:spcPct val="0"/>
+                  </a:spcBef>
+                  <a:spcAft>
+                    <a:spcPct val="0"/>
+                  </a:spcAft>
+                  <a:buClrTx/>
+                  <a:buSzTx/>
+                  <a:buFontTx/>
+                  <a:buNone/>
+                  <a:tabLst/>
+                  <a:defRPr/>
+                </a:pPr>
+                <a:endParaRPr kumimoji="0" lang="en-GB" sz="1800" b="0" i="0" u="none" strike="noStrike" kern="0" cap="none" spc="0" normalizeH="0" baseline="0" noProof="0" dirty="0" err="1">
+                  <a:ln>
+                    <a:noFill/>
+                  </a:ln>
+                  <a:gradFill>
+                    <a:gsLst>
+                      <a:gs pos="0">
+                        <a:srgbClr val="FFFFFF"/>
+                      </a:gs>
+                      <a:gs pos="100000">
+                        <a:srgbClr val="FFFFFF"/>
+                      </a:gs>
+                    </a:gsLst>
+                    <a:lin ang="5400000" scaled="0"/>
+                  </a:gradFill>
+                  <a:effectLst/>
+                  <a:uLnTx/>
+                  <a:uFillTx/>
+                  <a:latin typeface="Klavika Regular"/>
+                  <a:ea typeface="Segoe UI" pitchFamily="34" charset="0"/>
+                  <a:cs typeface="Segoe UI" pitchFamily="34" charset="0"/>
+                </a:endParaRPr>
+              </a:p>
+            </p:txBody>
+          </p:sp>
+        </p:grpSp>
+        <p:grpSp>
+          <p:nvGrpSpPr>
+            <p:cNvPr id="47" name="Group 46">
               <a:extLst>
                 <a:ext uri="{FF2B5EF4-FFF2-40B4-BE49-F238E27FC236}">
-                  <a16:creationId xmlns:a16="http://schemas.microsoft.com/office/drawing/2014/main" id="{3F561B45-DDC4-EBAA-A5CF-8FC6140B0D80}"/>
+                  <a16:creationId xmlns:a16="http://schemas.microsoft.com/office/drawing/2014/main" id="{51E95FE4-C20B-3942-CFB0-E2EAF0C67BAF}"/>
                 </a:ext>
               </a:extLst>
             </p:cNvPr>
-            <p:cNvSpPr/>
+            <p:cNvGrpSpPr/>
             <p:nvPr/>
-          </p:nvSpPr>
-          <p:spPr bwMode="auto">
-            <a:xfrm>
-              <a:off x="6777933" y="4956926"/>
+          </p:nvGrpSpPr>
+          <p:grpSpPr>
+            <a:xfrm rot="5400000">
+              <a:off x="6617512" y="4913772"/>
               <a:ext cx="914401" cy="914401"/>
+              <a:chOff x="6777933" y="4956926"/>
+              <a:chExt cx="914401" cy="914401"/>
             </a:xfrm>
-            <a:prstGeom prst="rect">
-              <a:avLst/>
-            </a:prstGeom>
-            <a:noFill/>
-            <a:ln w="38100" cap="flat" cmpd="sng" algn="ctr">
-              <a:solidFill>
-                <a:srgbClr val="000000"/>
-              </a:solidFill>
-              <a:prstDash val="solid"/>
-              <a:headEnd type="none" w="med" len="med"/>
-              <a:tailEnd type="none" w="med" len="med"/>
-            </a:ln>
-            <a:effectLst/>
-          </p:spPr>
-          <p:txBody>
-            <a:bodyPr rot="0" spcFirstLastPara="0" vertOverflow="overflow" horzOverflow="overflow" vert="horz" wrap="square" lIns="182880" tIns="146304" rIns="182880" bIns="146304" numCol="1" spcCol="0" rtlCol="0" fromWordArt="0" anchor="t" anchorCtr="0" forceAA="0" compatLnSpc="1">
-              <a:prstTxWarp prst="textNoShape">
+          </p:grpSpPr>
+          <p:pic>
+            <p:nvPicPr>
+              <p:cNvPr id="48" name="Graphic 47" descr="Chevron arrows with solid fill">
+                <a:extLst>
+                  <a:ext uri="{FF2B5EF4-FFF2-40B4-BE49-F238E27FC236}">
+                    <a16:creationId xmlns:a16="http://schemas.microsoft.com/office/drawing/2014/main" id="{C1EE30DF-602B-3401-E725-365F60A65909}"/>
+                  </a:ext>
+                </a:extLst>
+              </p:cNvPr>
+              <p:cNvPicPr>
+                <a:picLocks noChangeAspect="1"/>
+              </p:cNvPicPr>
+              <p:nvPr/>
+            </p:nvPicPr>
+            <p:blipFill>
+              <a:blip r:embed="rId3">
+                <a:extLst>
+                  <a:ext uri="{96DAC541-7B7A-43D3-8B79-37D633B846F1}">
+                    <asvg:svgBlip xmlns:asvg="http://schemas.microsoft.com/office/drawing/2016/SVG/main" r:embed="rId4"/>
+                  </a:ext>
+                </a:extLst>
+              </a:blip>
+              <a:stretch>
+                <a:fillRect/>
+              </a:stretch>
+            </p:blipFill>
+            <p:spPr>
+              <a:xfrm rot="10800000">
+                <a:off x="6777934" y="4956926"/>
+                <a:ext cx="914400" cy="914400"/>
+              </a:xfrm>
+              <a:prstGeom prst="rect">
                 <a:avLst/>
-              </a:prstTxWarp>
-              <a:noAutofit/>
-            </a:bodyPr>
-            <a:lstStyle/>
-            <a:p>
-              <a:pPr marL="0" marR="0" lvl="0" indent="0" defTabSz="932472" eaLnBrk="1" fontAlgn="base" latinLnBrk="0" hangingPunct="1">
-                <a:lnSpc>
-                  <a:spcPct val="100000"/>
-                </a:lnSpc>
-                <a:spcBef>
-                  <a:spcPct val="0"/>
-                </a:spcBef>
-                <a:spcAft>
-                  <a:spcPct val="0"/>
-                </a:spcAft>
-                <a:buClrTx/>
-                <a:buSzTx/>
-                <a:buFontTx/>
-                <a:buNone/>
-                <a:tabLst/>
-                <a:defRPr/>
-              </a:pPr>
-              <a:endParaRPr kumimoji="0" lang="en-GB" sz="1800" b="0" i="0" u="none" strike="noStrike" kern="0" cap="none" spc="0" normalizeH="0" baseline="0" noProof="0" dirty="0" err="1">
-                <a:ln>
-                  <a:noFill/>
-                </a:ln>
-                <a:gradFill>
-                  <a:gsLst>
-                    <a:gs pos="0">
-                      <a:srgbClr val="FFFFFF"/>
-                    </a:gs>
-                    <a:gs pos="100000">
-                      <a:srgbClr val="FFFFFF"/>
-                    </a:gs>
-                  </a:gsLst>
-                  <a:lin ang="5400000" scaled="0"/>
-                </a:gradFill>
-                <a:effectLst/>
-                <a:uLnTx/>
-                <a:uFillTx/>
-                <a:latin typeface="Klavika Regular"/>
-                <a:ea typeface="Segoe UI" pitchFamily="34" charset="0"/>
-                <a:cs typeface="Segoe UI" pitchFamily="34" charset="0"/>
-              </a:endParaRPr>
-            </a:p>
-          </p:txBody>
-        </p:sp>
-      </p:grpSp>
-      <p:grpSp>
-        <p:nvGrpSpPr>
-          <p:cNvPr id="47" name="Group 46">
-            <a:extLst>
-              <a:ext uri="{FF2B5EF4-FFF2-40B4-BE49-F238E27FC236}">
-                <a16:creationId xmlns:a16="http://schemas.microsoft.com/office/drawing/2014/main" id="{51E95FE4-C20B-3942-CFB0-E2EAF0C67BAF}"/>
-              </a:ext>
-            </a:extLst>
-          </p:cNvPr>
-          <p:cNvGrpSpPr/>
-          <p:nvPr/>
-        </p:nvGrpSpPr>
-        <p:grpSpPr>
-          <a:xfrm rot="5400000">
-            <a:off x="6617512" y="4913772"/>
-            <a:ext cx="914401" cy="914401"/>
-            <a:chOff x="6777933" y="4956926"/>
-            <a:chExt cx="914401" cy="914401"/>
-          </a:xfrm>
-        </p:grpSpPr>
-        <p:pic>
-          <p:nvPicPr>
-            <p:cNvPr id="48" name="Graphic 47" descr="Chevron arrows with solid fill">
+              </a:prstGeom>
+            </p:spPr>
+          </p:pic>
+          <p:sp>
+            <p:nvSpPr>
+              <p:cNvPr id="49" name="Rectangle 48">
+                <a:extLst>
+                  <a:ext uri="{FF2B5EF4-FFF2-40B4-BE49-F238E27FC236}">
+                    <a16:creationId xmlns:a16="http://schemas.microsoft.com/office/drawing/2014/main" id="{FC9308D8-8F86-BF97-28D5-0949C54AEF03}"/>
+                  </a:ext>
+                </a:extLst>
+              </p:cNvPr>
+              <p:cNvSpPr/>
+              <p:nvPr/>
+            </p:nvSpPr>
+            <p:spPr bwMode="auto">
+              <a:xfrm>
+                <a:off x="6777933" y="4956926"/>
+                <a:ext cx="914401" cy="914401"/>
+              </a:xfrm>
+              <a:prstGeom prst="rect">
+                <a:avLst/>
+              </a:prstGeom>
+              <a:noFill/>
+              <a:ln w="38100" cap="flat" cmpd="sng" algn="ctr">
+                <a:solidFill>
+                  <a:srgbClr val="000000"/>
+                </a:solidFill>
+                <a:prstDash val="solid"/>
+                <a:headEnd type="none" w="med" len="med"/>
+                <a:tailEnd type="none" w="med" len="med"/>
+              </a:ln>
+              <a:effectLst/>
+            </p:spPr>
+            <p:txBody>
+              <a:bodyPr rot="0" spcFirstLastPara="0" vertOverflow="overflow" horzOverflow="overflow" vert="horz" wrap="square" lIns="182880" tIns="146304" rIns="182880" bIns="146304" numCol="1" spcCol="0" rtlCol="0" fromWordArt="0" anchor="t" anchorCtr="0" forceAA="0" compatLnSpc="1">
+                <a:prstTxWarp prst="textNoShape">
+                  <a:avLst/>
+                </a:prstTxWarp>
+                <a:noAutofit/>
+              </a:bodyPr>
+              <a:lstStyle/>
+              <a:p>
+                <a:pPr marL="0" marR="0" lvl="0" indent="0" defTabSz="932472" eaLnBrk="1" fontAlgn="base" latinLnBrk="0" hangingPunct="1">
+                  <a:lnSpc>
+                    <a:spcPct val="100000"/>
+                  </a:lnSpc>
+                  <a:spcBef>
+                    <a:spcPct val="0"/>
+                  </a:spcBef>
+                  <a:spcAft>
+                    <a:spcPct val="0"/>
+                  </a:spcAft>
+                  <a:buClrTx/>
+                  <a:buSzTx/>
+                  <a:buFontTx/>
+                  <a:buNone/>
+                  <a:tabLst/>
+                  <a:defRPr/>
+                </a:pPr>
+                <a:endParaRPr kumimoji="0" lang="en-GB" sz="1800" b="0" i="0" u="none" strike="noStrike" kern="0" cap="none" spc="0" normalizeH="0" baseline="0" noProof="0" dirty="0" err="1">
+                  <a:ln>
+                    <a:noFill/>
+                  </a:ln>
+                  <a:gradFill>
+                    <a:gsLst>
+                      <a:gs pos="0">
+                        <a:srgbClr val="FFFFFF"/>
+                      </a:gs>
+                      <a:gs pos="100000">
+                        <a:srgbClr val="FFFFFF"/>
+                      </a:gs>
+                    </a:gsLst>
+                    <a:lin ang="5400000" scaled="0"/>
+                  </a:gradFill>
+                  <a:effectLst/>
+                  <a:uLnTx/>
+                  <a:uFillTx/>
+                  <a:latin typeface="Klavika Regular"/>
+                  <a:ea typeface="Segoe UI" pitchFamily="34" charset="0"/>
+                  <a:cs typeface="Segoe UI" pitchFamily="34" charset="0"/>
+                </a:endParaRPr>
+              </a:p>
+            </p:txBody>
+          </p:sp>
+        </p:grpSp>
+        <p:grpSp>
+          <p:nvGrpSpPr>
+            <p:cNvPr id="50" name="Group 49">
               <a:extLst>
                 <a:ext uri="{FF2B5EF4-FFF2-40B4-BE49-F238E27FC236}">
-                  <a16:creationId xmlns:a16="http://schemas.microsoft.com/office/drawing/2014/main" id="{C1EE30DF-602B-3401-E725-365F60A65909}"/>
+                  <a16:creationId xmlns:a16="http://schemas.microsoft.com/office/drawing/2014/main" id="{B67CD042-4161-6A57-4273-D5825E61A143}"/>
                 </a:ext>
               </a:extLst>
             </p:cNvPr>
-            <p:cNvPicPr>
-              <a:picLocks noChangeAspect="1"/>
-            </p:cNvPicPr>
+            <p:cNvGrpSpPr/>
             <p:nvPr/>
-          </p:nvPicPr>
-          <p:blipFill>
-            <a:blip r:embed="rId3">
-              <a:extLst>
-                <a:ext uri="{96DAC541-7B7A-43D3-8B79-37D633B846F1}">
-                  <asvg:svgBlip xmlns:asvg="http://schemas.microsoft.com/office/drawing/2016/SVG/main" r:embed="rId4"/>
-                </a:ext>
-              </a:extLst>
-            </a:blip>
-            <a:stretch>
-              <a:fillRect/>
-            </a:stretch>
-          </p:blipFill>
-          <p:spPr>
-            <a:xfrm rot="10800000">
-              <a:off x="6777934" y="4956926"/>
-              <a:ext cx="914400" cy="914400"/>
+          </p:nvGrpSpPr>
+          <p:grpSpPr>
+            <a:xfrm rot="16200000">
+              <a:off x="7693335" y="4913772"/>
+              <a:ext cx="914401" cy="914401"/>
+              <a:chOff x="6777933" y="4956926"/>
+              <a:chExt cx="914401" cy="914401"/>
             </a:xfrm>
-            <a:prstGeom prst="rect">
-              <a:avLst/>
-            </a:prstGeom>
-          </p:spPr>
-        </p:pic>
-        <p:sp>
-          <p:nvSpPr>
-            <p:cNvPr id="49" name="Rectangle 48">
+          </p:grpSpPr>
+          <p:pic>
+            <p:nvPicPr>
+              <p:cNvPr id="51" name="Graphic 50" descr="Chevron arrows with solid fill">
+                <a:extLst>
+                  <a:ext uri="{FF2B5EF4-FFF2-40B4-BE49-F238E27FC236}">
+                    <a16:creationId xmlns:a16="http://schemas.microsoft.com/office/drawing/2014/main" id="{8801D0D2-0A17-7F94-2FD5-AFA8F2819CA8}"/>
+                  </a:ext>
+                </a:extLst>
+              </p:cNvPr>
+              <p:cNvPicPr>
+                <a:picLocks noChangeAspect="1"/>
+              </p:cNvPicPr>
+              <p:nvPr/>
+            </p:nvPicPr>
+            <p:blipFill>
+              <a:blip r:embed="rId3">
+                <a:extLst>
+                  <a:ext uri="{96DAC541-7B7A-43D3-8B79-37D633B846F1}">
+                    <asvg:svgBlip xmlns:asvg="http://schemas.microsoft.com/office/drawing/2016/SVG/main" r:embed="rId4"/>
+                  </a:ext>
+                </a:extLst>
+              </a:blip>
+              <a:stretch>
+                <a:fillRect/>
+              </a:stretch>
+            </p:blipFill>
+            <p:spPr>
+              <a:xfrm rot="10800000">
+                <a:off x="6777934" y="4956926"/>
+                <a:ext cx="914400" cy="914400"/>
+              </a:xfrm>
+              <a:prstGeom prst="rect">
+                <a:avLst/>
+              </a:prstGeom>
+            </p:spPr>
+          </p:pic>
+          <p:sp>
+            <p:nvSpPr>
+              <p:cNvPr id="52" name="Rectangle 51">
+                <a:extLst>
+                  <a:ext uri="{FF2B5EF4-FFF2-40B4-BE49-F238E27FC236}">
+                    <a16:creationId xmlns:a16="http://schemas.microsoft.com/office/drawing/2014/main" id="{AF714858-A000-C8DD-BB0A-7199A5C1737A}"/>
+                  </a:ext>
+                </a:extLst>
+              </p:cNvPr>
+              <p:cNvSpPr/>
+              <p:nvPr/>
+            </p:nvSpPr>
+            <p:spPr bwMode="auto">
+              <a:xfrm>
+                <a:off x="6777933" y="4956926"/>
+                <a:ext cx="914401" cy="914401"/>
+              </a:xfrm>
+              <a:prstGeom prst="rect">
+                <a:avLst/>
+              </a:prstGeom>
+              <a:noFill/>
+              <a:ln w="38100" cap="flat" cmpd="sng" algn="ctr">
+                <a:solidFill>
+                  <a:srgbClr val="000000"/>
+                </a:solidFill>
+                <a:prstDash val="solid"/>
+                <a:headEnd type="none" w="med" len="med"/>
+                <a:tailEnd type="none" w="med" len="med"/>
+              </a:ln>
+              <a:effectLst/>
+            </p:spPr>
+            <p:txBody>
+              <a:bodyPr rot="0" spcFirstLastPara="0" vertOverflow="overflow" horzOverflow="overflow" vert="horz" wrap="square" lIns="182880" tIns="146304" rIns="182880" bIns="146304" numCol="1" spcCol="0" rtlCol="0" fromWordArt="0" anchor="t" anchorCtr="0" forceAA="0" compatLnSpc="1">
+                <a:prstTxWarp prst="textNoShape">
+                  <a:avLst/>
+                </a:prstTxWarp>
+                <a:noAutofit/>
+              </a:bodyPr>
+              <a:lstStyle/>
+              <a:p>
+                <a:pPr marL="0" marR="0" lvl="0" indent="0" defTabSz="932472" eaLnBrk="1" fontAlgn="base" latinLnBrk="0" hangingPunct="1">
+                  <a:lnSpc>
+                    <a:spcPct val="100000"/>
+                  </a:lnSpc>
+                  <a:spcBef>
+                    <a:spcPct val="0"/>
+                  </a:spcBef>
+                  <a:spcAft>
+                    <a:spcPct val="0"/>
+                  </a:spcAft>
+                  <a:buClrTx/>
+                  <a:buSzTx/>
+                  <a:buFontTx/>
+                  <a:buNone/>
+                  <a:tabLst/>
+                  <a:defRPr/>
+                </a:pPr>
+                <a:endParaRPr kumimoji="0" lang="en-GB" sz="1800" b="0" i="0" u="none" strike="noStrike" kern="0" cap="none" spc="0" normalizeH="0" baseline="0" noProof="0" dirty="0" err="1">
+                  <a:ln>
+                    <a:noFill/>
+                  </a:ln>
+                  <a:gradFill>
+                    <a:gsLst>
+                      <a:gs pos="0">
+                        <a:srgbClr val="FFFFFF"/>
+                      </a:gs>
+                      <a:gs pos="100000">
+                        <a:srgbClr val="FFFFFF"/>
+                      </a:gs>
+                    </a:gsLst>
+                    <a:lin ang="5400000" scaled="0"/>
+                  </a:gradFill>
+                  <a:effectLst/>
+                  <a:uLnTx/>
+                  <a:uFillTx/>
+                  <a:latin typeface="Klavika Regular"/>
+                  <a:ea typeface="Segoe UI" pitchFamily="34" charset="0"/>
+                  <a:cs typeface="Segoe UI" pitchFamily="34" charset="0"/>
+                </a:endParaRPr>
+              </a:p>
+            </p:txBody>
+          </p:sp>
+        </p:grpSp>
+        <p:grpSp>
+          <p:nvGrpSpPr>
+            <p:cNvPr id="53" name="Group 52">
               <a:extLst>
                 <a:ext uri="{FF2B5EF4-FFF2-40B4-BE49-F238E27FC236}">
-                  <a16:creationId xmlns:a16="http://schemas.microsoft.com/office/drawing/2014/main" id="{FC9308D8-8F86-BF97-28D5-0949C54AEF03}"/>
+                  <a16:creationId xmlns:a16="http://schemas.microsoft.com/office/drawing/2014/main" id="{9BE2784E-2B14-97F2-C676-6AA58F7B9EAB}"/>
                 </a:ext>
               </a:extLst>
             </p:cNvPr>
-            <p:cNvSpPr/>
+            <p:cNvGrpSpPr/>
             <p:nvPr/>
-          </p:nvSpPr>
-          <p:spPr bwMode="auto">
-            <a:xfrm>
-              <a:off x="6777933" y="4956926"/>
+          </p:nvGrpSpPr>
+          <p:grpSpPr>
+            <a:xfrm rot="10800000">
+              <a:off x="9895973" y="4892483"/>
               <a:ext cx="914401" cy="914401"/>
+              <a:chOff x="6777933" y="4956926"/>
+              <a:chExt cx="914401" cy="914401"/>
             </a:xfrm>
-            <a:prstGeom prst="rect">
-              <a:avLst/>
-            </a:prstGeom>
-            <a:noFill/>
-            <a:ln w="38100" cap="flat" cmpd="sng" algn="ctr">
-              <a:solidFill>
-                <a:srgbClr val="000000"/>
-              </a:solidFill>
-              <a:prstDash val="solid"/>
-              <a:headEnd type="none" w="med" len="med"/>
-              <a:tailEnd type="none" w="med" len="med"/>
-            </a:ln>
-            <a:effectLst/>
-          </p:spPr>
-          <p:txBody>
-            <a:bodyPr rot="0" spcFirstLastPara="0" vertOverflow="overflow" horzOverflow="overflow" vert="horz" wrap="square" lIns="182880" tIns="146304" rIns="182880" bIns="146304" numCol="1" spcCol="0" rtlCol="0" fromWordArt="0" anchor="t" anchorCtr="0" forceAA="0" compatLnSpc="1">
-              <a:prstTxWarp prst="textNoShape">
+          </p:grpSpPr>
+          <p:pic>
+            <p:nvPicPr>
+              <p:cNvPr id="54" name="Graphic 53" descr="Chevron arrows with solid fill">
+                <a:extLst>
+                  <a:ext uri="{FF2B5EF4-FFF2-40B4-BE49-F238E27FC236}">
+                    <a16:creationId xmlns:a16="http://schemas.microsoft.com/office/drawing/2014/main" id="{61F4F918-83BE-9F7F-E3A4-72BB965029EC}"/>
+                  </a:ext>
+                </a:extLst>
+              </p:cNvPr>
+              <p:cNvPicPr>
+                <a:picLocks noChangeAspect="1"/>
+              </p:cNvPicPr>
+              <p:nvPr/>
+            </p:nvPicPr>
+            <p:blipFill>
+              <a:blip r:embed="rId3">
+                <a:extLst>
+                  <a:ext uri="{96DAC541-7B7A-43D3-8B79-37D633B846F1}">
+                    <asvg:svgBlip xmlns:asvg="http://schemas.microsoft.com/office/drawing/2016/SVG/main" r:embed="rId4"/>
+                  </a:ext>
+                </a:extLst>
+              </a:blip>
+              <a:stretch>
+                <a:fillRect/>
+              </a:stretch>
+            </p:blipFill>
+            <p:spPr>
+              <a:xfrm rot="10800000">
+                <a:off x="6777934" y="4956926"/>
+                <a:ext cx="914400" cy="914400"/>
+              </a:xfrm>
+              <a:prstGeom prst="rect">
                 <a:avLst/>
-              </a:prstTxWarp>
-              <a:noAutofit/>
-            </a:bodyPr>
-            <a:lstStyle/>
-            <a:p>
-              <a:pPr marL="0" marR="0" lvl="0" indent="0" defTabSz="932472" eaLnBrk="1" fontAlgn="base" latinLnBrk="0" hangingPunct="1">
-                <a:lnSpc>
-                  <a:spcPct val="100000"/>
-                </a:lnSpc>
-                <a:spcBef>
-                  <a:spcPct val="0"/>
-                </a:spcBef>
-                <a:spcAft>
-                  <a:spcPct val="0"/>
-                </a:spcAft>
-                <a:buClrTx/>
-                <a:buSzTx/>
-                <a:buFontTx/>
-                <a:buNone/>
-                <a:tabLst/>
-                <a:defRPr/>
-              </a:pPr>
-              <a:endParaRPr kumimoji="0" lang="en-GB" sz="1800" b="0" i="0" u="none" strike="noStrike" kern="0" cap="none" spc="0" normalizeH="0" baseline="0" noProof="0" dirty="0" err="1">
-                <a:ln>
-                  <a:noFill/>
-                </a:ln>
-                <a:gradFill>
-                  <a:gsLst>
-                    <a:gs pos="0">
-                      <a:srgbClr val="FFFFFF"/>
-                    </a:gs>
-                    <a:gs pos="100000">
-                      <a:srgbClr val="FFFFFF"/>
-                    </a:gs>
-                  </a:gsLst>
-                  <a:lin ang="5400000" scaled="0"/>
-                </a:gradFill>
-                <a:effectLst/>
-                <a:uLnTx/>
-                <a:uFillTx/>
-                <a:latin typeface="Klavika Regular"/>
-                <a:ea typeface="Segoe UI" pitchFamily="34" charset="0"/>
-                <a:cs typeface="Segoe UI" pitchFamily="34" charset="0"/>
-              </a:endParaRPr>
-            </a:p>
-          </p:txBody>
-        </p:sp>
-      </p:grpSp>
-      <p:grpSp>
-        <p:nvGrpSpPr>
-          <p:cNvPr id="50" name="Group 49">
-            <a:extLst>
-              <a:ext uri="{FF2B5EF4-FFF2-40B4-BE49-F238E27FC236}">
-                <a16:creationId xmlns:a16="http://schemas.microsoft.com/office/drawing/2014/main" id="{B67CD042-4161-6A57-4273-D5825E61A143}"/>
-              </a:ext>
-            </a:extLst>
-          </p:cNvPr>
-          <p:cNvGrpSpPr/>
-          <p:nvPr/>
-        </p:nvGrpSpPr>
-        <p:grpSpPr>
-          <a:xfrm rot="16200000">
-            <a:off x="7693335" y="4913772"/>
-            <a:ext cx="914401" cy="914401"/>
-            <a:chOff x="6777933" y="4956926"/>
-            <a:chExt cx="914401" cy="914401"/>
-          </a:xfrm>
-        </p:grpSpPr>
-        <p:pic>
-          <p:nvPicPr>
-            <p:cNvPr id="51" name="Graphic 50" descr="Chevron arrows with solid fill">
-              <a:extLst>
-                <a:ext uri="{FF2B5EF4-FFF2-40B4-BE49-F238E27FC236}">
-                  <a16:creationId xmlns:a16="http://schemas.microsoft.com/office/drawing/2014/main" id="{8801D0D2-0A17-7F94-2FD5-AFA8F2819CA8}"/>
-                </a:ext>
-              </a:extLst>
-            </p:cNvPr>
-            <p:cNvPicPr>
-              <a:picLocks noChangeAspect="1"/>
-            </p:cNvPicPr>
-            <p:nvPr/>
-          </p:nvPicPr>
-          <p:blipFill>
-            <a:blip r:embed="rId3">
-              <a:extLst>
-                <a:ext uri="{96DAC541-7B7A-43D3-8B79-37D633B846F1}">
-                  <asvg:svgBlip xmlns:asvg="http://schemas.microsoft.com/office/drawing/2016/SVG/main" r:embed="rId4"/>
-                </a:ext>
-              </a:extLst>
-            </a:blip>
-            <a:stretch>
-              <a:fillRect/>
-            </a:stretch>
-          </p:blipFill>
-          <p:spPr>
-            <a:xfrm rot="10800000">
-              <a:off x="6777934" y="4956926"/>
-              <a:ext cx="914400" cy="914400"/>
-            </a:xfrm>
-            <a:prstGeom prst="rect">
-              <a:avLst/>
-            </a:prstGeom>
-          </p:spPr>
-        </p:pic>
-        <p:sp>
-          <p:nvSpPr>
-            <p:cNvPr id="52" name="Rectangle 51">
-              <a:extLst>
-                <a:ext uri="{FF2B5EF4-FFF2-40B4-BE49-F238E27FC236}">
-                  <a16:creationId xmlns:a16="http://schemas.microsoft.com/office/drawing/2014/main" id="{AF714858-A000-C8DD-BB0A-7199A5C1737A}"/>
-                </a:ext>
-              </a:extLst>
-            </p:cNvPr>
-            <p:cNvSpPr/>
-            <p:nvPr/>
-          </p:nvSpPr>
-          <p:spPr bwMode="auto">
-            <a:xfrm>
-              <a:off x="6777933" y="4956926"/>
-              <a:ext cx="914401" cy="914401"/>
-            </a:xfrm>
-            <a:prstGeom prst="rect">
-              <a:avLst/>
-            </a:prstGeom>
-            <a:noFill/>
-            <a:ln w="38100" cap="flat" cmpd="sng" algn="ctr">
-              <a:solidFill>
-                <a:srgbClr val="000000"/>
-              </a:solidFill>
-              <a:prstDash val="solid"/>
-              <a:headEnd type="none" w="med" len="med"/>
-              <a:tailEnd type="none" w="med" len="med"/>
-            </a:ln>
-            <a:effectLst/>
-          </p:spPr>
-          <p:txBody>
-            <a:bodyPr rot="0" spcFirstLastPara="0" vertOverflow="overflow" horzOverflow="overflow" vert="horz" wrap="square" lIns="182880" tIns="146304" rIns="182880" bIns="146304" numCol="1" spcCol="0" rtlCol="0" fromWordArt="0" anchor="t" anchorCtr="0" forceAA="0" compatLnSpc="1">
-              <a:prstTxWarp prst="textNoShape">
+              </a:prstGeom>
+            </p:spPr>
+          </p:pic>
+          <p:sp>
+            <p:nvSpPr>
+              <p:cNvPr id="55" name="Rectangle 54">
+                <a:extLst>
+                  <a:ext uri="{FF2B5EF4-FFF2-40B4-BE49-F238E27FC236}">
+                    <a16:creationId xmlns:a16="http://schemas.microsoft.com/office/drawing/2014/main" id="{A202DF25-930B-343F-4056-1898C0B9B7F5}"/>
+                  </a:ext>
+                </a:extLst>
+              </p:cNvPr>
+              <p:cNvSpPr/>
+              <p:nvPr/>
+            </p:nvSpPr>
+            <p:spPr bwMode="auto">
+              <a:xfrm>
+                <a:off x="6777933" y="4956926"/>
+                <a:ext cx="914401" cy="914401"/>
+              </a:xfrm>
+              <a:prstGeom prst="rect">
                 <a:avLst/>
-              </a:prstTxWarp>
-              <a:noAutofit/>
-            </a:bodyPr>
-            <a:lstStyle/>
-            <a:p>
-              <a:pPr marL="0" marR="0" lvl="0" indent="0" defTabSz="932472" eaLnBrk="1" fontAlgn="base" latinLnBrk="0" hangingPunct="1">
-                <a:lnSpc>
-                  <a:spcPct val="100000"/>
-                </a:lnSpc>
-                <a:spcBef>
-                  <a:spcPct val="0"/>
-                </a:spcBef>
-                <a:spcAft>
-                  <a:spcPct val="0"/>
-                </a:spcAft>
-                <a:buClrTx/>
-                <a:buSzTx/>
-                <a:buFontTx/>
-                <a:buNone/>
-                <a:tabLst/>
-                <a:defRPr/>
-              </a:pPr>
-              <a:endParaRPr kumimoji="0" lang="en-GB" sz="1800" b="0" i="0" u="none" strike="noStrike" kern="0" cap="none" spc="0" normalizeH="0" baseline="0" noProof="0" dirty="0" err="1">
-                <a:ln>
-                  <a:noFill/>
-                </a:ln>
-                <a:gradFill>
-                  <a:gsLst>
-                    <a:gs pos="0">
-                      <a:srgbClr val="FFFFFF"/>
-                    </a:gs>
-                    <a:gs pos="100000">
-                      <a:srgbClr val="FFFFFF"/>
-                    </a:gs>
-                  </a:gsLst>
-                  <a:lin ang="5400000" scaled="0"/>
-                </a:gradFill>
-                <a:effectLst/>
-                <a:uLnTx/>
-                <a:uFillTx/>
-                <a:latin typeface="Klavika Regular"/>
-                <a:ea typeface="Segoe UI" pitchFamily="34" charset="0"/>
-                <a:cs typeface="Segoe UI" pitchFamily="34" charset="0"/>
-              </a:endParaRPr>
-            </a:p>
-          </p:txBody>
-        </p:sp>
-      </p:grpSp>
-      <p:grpSp>
-        <p:nvGrpSpPr>
-          <p:cNvPr id="53" name="Group 52">
-            <a:extLst>
-              <a:ext uri="{FF2B5EF4-FFF2-40B4-BE49-F238E27FC236}">
-                <a16:creationId xmlns:a16="http://schemas.microsoft.com/office/drawing/2014/main" id="{9BE2784E-2B14-97F2-C676-6AA58F7B9EAB}"/>
-              </a:ext>
-            </a:extLst>
-          </p:cNvPr>
-          <p:cNvGrpSpPr/>
-          <p:nvPr/>
-        </p:nvGrpSpPr>
-        <p:grpSpPr>
-          <a:xfrm rot="10800000">
-            <a:off x="9895973" y="4892483"/>
-            <a:ext cx="914401" cy="914401"/>
-            <a:chOff x="6777933" y="4956926"/>
-            <a:chExt cx="914401" cy="914401"/>
-          </a:xfrm>
-        </p:grpSpPr>
-        <p:pic>
-          <p:nvPicPr>
-            <p:cNvPr id="54" name="Graphic 53" descr="Chevron arrows with solid fill">
-              <a:extLst>
-                <a:ext uri="{FF2B5EF4-FFF2-40B4-BE49-F238E27FC236}">
-                  <a16:creationId xmlns:a16="http://schemas.microsoft.com/office/drawing/2014/main" id="{61F4F918-83BE-9F7F-E3A4-72BB965029EC}"/>
-                </a:ext>
-              </a:extLst>
-            </p:cNvPr>
-            <p:cNvPicPr>
-              <a:picLocks noChangeAspect="1"/>
-            </p:cNvPicPr>
-            <p:nvPr/>
-          </p:nvPicPr>
-          <p:blipFill>
-            <a:blip r:embed="rId3">
-              <a:extLst>
-                <a:ext uri="{96DAC541-7B7A-43D3-8B79-37D633B846F1}">
-                  <asvg:svgBlip xmlns:asvg="http://schemas.microsoft.com/office/drawing/2016/SVG/main" r:embed="rId4"/>
-                </a:ext>
-              </a:extLst>
-            </a:blip>
-            <a:stretch>
-              <a:fillRect/>
-            </a:stretch>
-          </p:blipFill>
-          <p:spPr>
-            <a:xfrm rot="10800000">
-              <a:off x="6777934" y="4956926"/>
-              <a:ext cx="914400" cy="914400"/>
-            </a:xfrm>
-            <a:prstGeom prst="rect">
-              <a:avLst/>
-            </a:prstGeom>
-          </p:spPr>
-        </p:pic>
-        <p:sp>
-          <p:nvSpPr>
-            <p:cNvPr id="55" name="Rectangle 54">
-              <a:extLst>
-                <a:ext uri="{FF2B5EF4-FFF2-40B4-BE49-F238E27FC236}">
-                  <a16:creationId xmlns:a16="http://schemas.microsoft.com/office/drawing/2014/main" id="{A202DF25-930B-343F-4056-1898C0B9B7F5}"/>
-                </a:ext>
-              </a:extLst>
-            </p:cNvPr>
-            <p:cNvSpPr/>
-            <p:nvPr/>
-          </p:nvSpPr>
-          <p:spPr bwMode="auto">
-            <a:xfrm>
-              <a:off x="6777933" y="4956926"/>
-              <a:ext cx="914401" cy="914401"/>
-            </a:xfrm>
-            <a:prstGeom prst="rect">
-              <a:avLst/>
-            </a:prstGeom>
-            <a:noFill/>
-            <a:ln w="38100" cap="flat" cmpd="sng" algn="ctr">
-              <a:solidFill>
-                <a:srgbClr val="000000"/>
-              </a:solidFill>
-              <a:prstDash val="solid"/>
-              <a:headEnd type="none" w="med" len="med"/>
-              <a:tailEnd type="none" w="med" len="med"/>
-            </a:ln>
-            <a:effectLst/>
-          </p:spPr>
-          <p:txBody>
-            <a:bodyPr rot="0" spcFirstLastPara="0" vertOverflow="overflow" horzOverflow="overflow" vert="horz" wrap="square" lIns="182880" tIns="146304" rIns="182880" bIns="146304" numCol="1" spcCol="0" rtlCol="0" fromWordArt="0" anchor="t" anchorCtr="0" forceAA="0" compatLnSpc="1">
-              <a:prstTxWarp prst="textNoShape">
-                <a:avLst/>
-              </a:prstTxWarp>
-              <a:noAutofit/>
-            </a:bodyPr>
-            <a:lstStyle/>
-            <a:p>
-              <a:pPr marL="0" marR="0" lvl="0" indent="0" defTabSz="932472" eaLnBrk="1" fontAlgn="base" latinLnBrk="0" hangingPunct="1">
-                <a:lnSpc>
-                  <a:spcPct val="100000"/>
-                </a:lnSpc>
-                <a:spcBef>
-                  <a:spcPct val="0"/>
-                </a:spcBef>
-                <a:spcAft>
-                  <a:spcPct val="0"/>
-                </a:spcAft>
-                <a:buClrTx/>
-                <a:buSzTx/>
-                <a:buFontTx/>
-                <a:buNone/>
-                <a:tabLst/>
-                <a:defRPr/>
-              </a:pPr>
-              <a:endParaRPr kumimoji="0" lang="en-GB" sz="1800" b="0" i="0" u="none" strike="noStrike" kern="0" cap="none" spc="0" normalizeH="0" baseline="0" noProof="0" dirty="0" err="1">
-                <a:ln>
-                  <a:noFill/>
-                </a:ln>
-                <a:gradFill>
-                  <a:gsLst>
-                    <a:gs pos="0">
-                      <a:srgbClr val="FFFFFF"/>
-                    </a:gs>
-                    <a:gs pos="100000">
-                      <a:srgbClr val="FFFFFF"/>
-                    </a:gs>
-                  </a:gsLst>
-                  <a:lin ang="5400000" scaled="0"/>
-                </a:gradFill>
-                <a:effectLst/>
-                <a:uLnTx/>
-                <a:uFillTx/>
-                <a:latin typeface="Klavika Regular"/>
-                <a:ea typeface="Segoe UI" pitchFamily="34" charset="0"/>
-                <a:cs typeface="Segoe UI" pitchFamily="34" charset="0"/>
-              </a:endParaRPr>
-            </a:p>
-          </p:txBody>
-        </p:sp>
+              </a:prstGeom>
+              <a:noFill/>
+              <a:ln w="38100" cap="flat" cmpd="sng" algn="ctr">
+                <a:solidFill>
+                  <a:srgbClr val="000000"/>
+                </a:solidFill>
+                <a:prstDash val="solid"/>
+                <a:headEnd type="none" w="med" len="med"/>
+                <a:tailEnd type="none" w="med" len="med"/>
+              </a:ln>
+              <a:effectLst/>
+            </p:spPr>
+            <p:txBody>
+              <a:bodyPr rot="0" spcFirstLastPara="0" vertOverflow="overflow" horzOverflow="overflow" vert="horz" wrap="square" lIns="182880" tIns="146304" rIns="182880" bIns="146304" numCol="1" spcCol="0" rtlCol="0" fromWordArt="0" anchor="t" anchorCtr="0" forceAA="0" compatLnSpc="1">
+                <a:prstTxWarp prst="textNoShape">
+                  <a:avLst/>
+                </a:prstTxWarp>
+                <a:noAutofit/>
+              </a:bodyPr>
+              <a:lstStyle/>
+              <a:p>
+                <a:pPr marL="0" marR="0" lvl="0" indent="0" defTabSz="932472" eaLnBrk="1" fontAlgn="base" latinLnBrk="0" hangingPunct="1">
+                  <a:lnSpc>
+                    <a:spcPct val="100000"/>
+                  </a:lnSpc>
+                  <a:spcBef>
+                    <a:spcPct val="0"/>
+                  </a:spcBef>
+                  <a:spcAft>
+                    <a:spcPct val="0"/>
+                  </a:spcAft>
+                  <a:buClrTx/>
+                  <a:buSzTx/>
+                  <a:buFontTx/>
+                  <a:buNone/>
+                  <a:tabLst/>
+                  <a:defRPr/>
+                </a:pPr>
+                <a:endParaRPr kumimoji="0" lang="en-GB" sz="1800" b="0" i="0" u="none" strike="noStrike" kern="0" cap="none" spc="0" normalizeH="0" baseline="0" noProof="0" dirty="0" err="1">
+                  <a:ln>
+                    <a:noFill/>
+                  </a:ln>
+                  <a:gradFill>
+                    <a:gsLst>
+                      <a:gs pos="0">
+                        <a:srgbClr val="FFFFFF"/>
+                      </a:gs>
+                      <a:gs pos="100000">
+                        <a:srgbClr val="FFFFFF"/>
+                      </a:gs>
+                    </a:gsLst>
+                    <a:lin ang="5400000" scaled="0"/>
+                  </a:gradFill>
+                  <a:effectLst/>
+                  <a:uLnTx/>
+                  <a:uFillTx/>
+                  <a:latin typeface="Klavika Regular"/>
+                  <a:ea typeface="Segoe UI" pitchFamily="34" charset="0"/>
+                  <a:cs typeface="Segoe UI" pitchFamily="34" charset="0"/>
+                </a:endParaRPr>
+              </a:p>
+            </p:txBody>
+          </p:sp>
+        </p:grpSp>
       </p:grpSp>
       <p:sp>
         <p:nvSpPr>
@@ -22483,7 +22650,7 @@
         </p:nvSpPr>
         <p:spPr bwMode="auto">
           <a:xfrm>
-            <a:off x="9126650" y="3399911"/>
+            <a:off x="9158400" y="3399911"/>
             <a:ext cx="294077" cy="516835"/>
           </a:xfrm>
           <a:prstGeom prst="rect">
@@ -22600,8 +22767,8 @@
         </p:nvCxnSpPr>
         <p:spPr>
           <a:xfrm flipV="1">
-            <a:off x="4640920" y="5377125"/>
-            <a:ext cx="1795599" cy="370536"/>
+            <a:off x="4908833" y="5367729"/>
+            <a:ext cx="1527686" cy="357547"/>
           </a:xfrm>
           <a:prstGeom prst="straightConnector1">
             <a:avLst/>
@@ -22610,6 +22777,123 @@
           <a:ln w="12700" cap="flat" cmpd="sng" algn="ctr">
             <a:solidFill>
               <a:srgbClr val="ED1C24"/>
+            </a:solidFill>
+            <a:prstDash val="solid"/>
+            <a:headEnd type="none" w="lg" len="med"/>
+            <a:tailEnd type="triangle"/>
+          </a:ln>
+          <a:effectLst/>
+        </p:spPr>
+      </p:cxnSp>
+      <p:sp>
+        <p:nvSpPr>
+          <p:cNvPr id="7" name="Rectangle 6">
+            <a:extLst>
+              <a:ext uri="{FF2B5EF4-FFF2-40B4-BE49-F238E27FC236}">
+                <a16:creationId xmlns:a16="http://schemas.microsoft.com/office/drawing/2014/main" id="{5A8ED71B-2C2A-05C8-E066-18E9A9AC05B9}"/>
+              </a:ext>
+            </a:extLst>
+          </p:cNvPr>
+          <p:cNvSpPr/>
+          <p:nvPr/>
+        </p:nvSpPr>
+        <p:spPr bwMode="auto">
+          <a:xfrm>
+            <a:off x="8824246" y="3397849"/>
+            <a:ext cx="294077" cy="516835"/>
+          </a:xfrm>
+          <a:prstGeom prst="rect">
+            <a:avLst/>
+          </a:prstGeom>
+          <a:noFill/>
+          <a:ln w="38100" cap="flat" cmpd="sng" algn="ctr">
+            <a:solidFill>
+              <a:srgbClr val="00B0F0"/>
+            </a:solidFill>
+            <a:prstDash val="solid"/>
+            <a:headEnd type="none" w="med" len="med"/>
+            <a:tailEnd type="none" w="med" len="med"/>
+          </a:ln>
+          <a:effectLst/>
+        </p:spPr>
+        <p:txBody>
+          <a:bodyPr rot="0" spcFirstLastPara="0" vertOverflow="overflow" horzOverflow="overflow" vert="horz" wrap="square" lIns="182880" tIns="146304" rIns="182880" bIns="146304" numCol="1" spcCol="0" rtlCol="0" fromWordArt="0" anchor="t" anchorCtr="0" forceAA="0" compatLnSpc="1">
+            <a:prstTxWarp prst="textNoShape">
+              <a:avLst/>
+            </a:prstTxWarp>
+            <a:noAutofit/>
+          </a:bodyPr>
+          <a:lstStyle/>
+          <a:p>
+            <a:pPr marL="0" marR="0" lvl="0" indent="0" defTabSz="932472" eaLnBrk="1" fontAlgn="base" latinLnBrk="0" hangingPunct="1">
+              <a:lnSpc>
+                <a:spcPct val="100000"/>
+              </a:lnSpc>
+              <a:spcBef>
+                <a:spcPct val="0"/>
+              </a:spcBef>
+              <a:spcAft>
+                <a:spcPct val="0"/>
+              </a:spcAft>
+              <a:buClrTx/>
+              <a:buSzTx/>
+              <a:buFontTx/>
+              <a:buNone/>
+              <a:tabLst/>
+              <a:defRPr/>
+            </a:pPr>
+            <a:endParaRPr kumimoji="0" lang="en-GB" sz="1800" b="0" i="0" u="none" strike="noStrike" kern="0" cap="none" spc="0" normalizeH="0" baseline="0" noProof="0" dirty="0" err="1">
+              <a:ln>
+                <a:noFill/>
+              </a:ln>
+              <a:gradFill>
+                <a:gsLst>
+                  <a:gs pos="0">
+                    <a:srgbClr val="FFFFFF"/>
+                  </a:gs>
+                  <a:gs pos="100000">
+                    <a:srgbClr val="FFFFFF"/>
+                  </a:gs>
+                </a:gsLst>
+                <a:lin ang="5400000" scaled="0"/>
+              </a:gradFill>
+              <a:effectLst/>
+              <a:uLnTx/>
+              <a:uFillTx/>
+              <a:latin typeface="Klavika Regular"/>
+              <a:ea typeface="Segoe UI" pitchFamily="34" charset="0"/>
+              <a:cs typeface="Segoe UI" pitchFamily="34" charset="0"/>
+            </a:endParaRPr>
+          </a:p>
+        </p:txBody>
+      </p:sp>
+      <p:cxnSp>
+        <p:nvCxnSpPr>
+          <p:cNvPr id="8" name="Straight Arrow Connector 7">
+            <a:extLst>
+              <a:ext uri="{FF2B5EF4-FFF2-40B4-BE49-F238E27FC236}">
+                <a16:creationId xmlns:a16="http://schemas.microsoft.com/office/drawing/2014/main" id="{207D279B-ACFD-FB8A-02B4-C5E220D621D3}"/>
+              </a:ext>
+            </a:extLst>
+          </p:cNvPr>
+          <p:cNvCxnSpPr>
+            <a:cxnSpLocks/>
+            <a:endCxn id="7" idx="1"/>
+          </p:cNvCxnSpPr>
+          <p:nvPr/>
+        </p:nvCxnSpPr>
+        <p:spPr>
+          <a:xfrm>
+            <a:off x="5253610" y="3250735"/>
+            <a:ext cx="3570636" cy="405532"/>
+          </a:xfrm>
+          <a:prstGeom prst="straightConnector1">
+            <a:avLst/>
+          </a:prstGeom>
+          <a:noFill/>
+          <a:ln w="12700" cap="flat" cmpd="sng" algn="ctr">
+            <a:solidFill>
+              <a:srgbClr val="00B0F0"/>
             </a:solidFill>
             <a:prstDash val="solid"/>
             <a:headEnd type="none" w="lg" len="med"/>
@@ -23234,21 +23518,21 @@
 </file>
 
 <file path=customXml/item1.xml><?xml version="1.0" encoding="utf-8"?>
+<TemplafySlideTemplateConfiguration><![CDATA[{"slideVersion":1,"isValidatorEnabled":false,"isLocked":false,"elementsMetadata":[],"slideId":"637629098472101399","enableDocumentContentUpdater":true,"version":"2.0"}]]></TemplafySlideTemplateConfiguration>
+</file>
+
+<file path=customXml/item2.xml><?xml version="1.0" encoding="utf-8"?>
 <TemplafySlideFormConfiguration><![CDATA[{"formFields":[],"formDataEntries":[]}]]></TemplafySlideFormConfiguration>
 </file>
 
-<file path=customXml/item2.xml><?xml version="1.0" encoding="utf-8"?>
-<TemplafySlideTemplateConfiguration><![CDATA[{"slideVersion":1,"isValidatorEnabled":false,"isLocked":false,"elementsMetadata":[],"slideId":"637629098472101399","enableDocumentContentUpdater":true,"version":"2.0"}]]></TemplafySlideTemplateConfiguration>
-</file>
-
 <file path=customXml/itemProps1.xml><?xml version="1.0" encoding="utf-8"?>
-<ds:datastoreItem xmlns:ds="http://schemas.openxmlformats.org/officeDocument/2006/customXml" ds:itemID="{E4185C24-1447-4288-BCBB-7ABBF03479A8}">
+<ds:datastoreItem xmlns:ds="http://schemas.openxmlformats.org/officeDocument/2006/customXml" ds:itemID="{3A7B4B56-D0D2-4135-A66A-EEF2C62C4256}">
   <ds:schemaRefs/>
 </ds:datastoreItem>
 </file>
 
 <file path=customXml/itemProps2.xml><?xml version="1.0" encoding="utf-8"?>
-<ds:datastoreItem xmlns:ds="http://schemas.openxmlformats.org/officeDocument/2006/customXml" ds:itemID="{3A7B4B56-D0D2-4135-A66A-EEF2C62C4256}">
+<ds:datastoreItem xmlns:ds="http://schemas.openxmlformats.org/officeDocument/2006/customXml" ds:itemID="{E4185C24-1447-4288-BCBB-7ABBF03479A8}">
   <ds:schemaRefs/>
 </ds:datastoreItem>
 </file>

</xml_diff>